<commit_message>
v3.6.5: Rebuild CEO deck with professional graphics + architecture cleanup
- Rebuilt CEO deck from scratch: 14 slides with programmatic SVG diagrams,
  20+ react-icons, gradient backgrounds, comparison tables, stat callouts
- Architecture pipeline diagram (Input→AIMDS→Ruflo→RuVector→AgentDB→SONA→Output)
- Timeline SVG with shipped badges and milestone markers
- Provider comparison table, performance benchmarks, deployment models
- Contact info on CTA slide (ruvnet.com | github | email)
- Simplified to RVF-only architecture (removed PostgresKnowledgeBase, RuvectorStore)
- Added MCP KB export/publish pipeline scripts
- Updated Dockerfile and startup script for RVF-native backend

Co-Authored-By: Claude Opus 4.6 <noreply@anthropic.com>
</commit_message>
<xml_diff>
--- a/docs/presentations/CEO-Deck-RuvNet-2026.pptx
+++ b/docs/presentations/CEO-Deck-RuvNet-2026.pptx
@@ -2536,16 +2536,42 @@
           </a:p>
         </p:txBody>
       </p:sp>
-      <p:sp>
-        <p:nvSpPr>
-          <p:cNvPr id="4" name="Text 2"/>
+      <p:pic>
+        <p:nvPicPr>
+          <p:cNvPr id="4" name="Image 0" descr="/Users/stuartkerr/Code/Ask-Ruvnet/Ask-Ruvnet/docs/presentations/images/01-architecture-overview.png">    </p:cNvPr>
+          <p:cNvPicPr>
+            <a:picLocks noChangeAspect="1"/>
+          </p:cNvPicPr>
+          <p:nvPr/>
+        </p:nvPicPr>
+        <p:blipFill>
+          <a:blip r:embed="rId1">
+            <a:alphaModFix amt="45000"/>
+          </a:blip>
+          <a:stretch>
+            <a:fillRect/>
+          </a:stretch>
+        </p:blipFill>
+        <p:spPr>
+          <a:xfrm>
+            <a:off x="6217920" y="1097280"/>
+            <a:ext cx="2743200" cy="1828800"/>
+          </a:xfrm>
+          <a:prstGeom prst="rect">
+            <a:avLst/>
+          </a:prstGeom>
+        </p:spPr>
+      </p:pic>
+      <p:sp>
+        <p:nvSpPr>
+          <p:cNvPr id="5" name="Text 2"/>
           <p:cNvSpPr/>
           <p:nvPr/>
         </p:nvSpPr>
         <p:spPr>
           <a:xfrm>
             <a:off x="731520" y="1463040"/>
-            <a:ext cx="7680960" cy="1463040"/>
+            <a:ext cx="5029200" cy="1463040"/>
           </a:xfrm>
           <a:prstGeom prst="rect">
             <a:avLst/>
@@ -2594,7 +2620,7 @@
       </p:sp>
       <p:sp>
         <p:nvSpPr>
-          <p:cNvPr id="5" name="Text 3"/>
+          <p:cNvPr id="6" name="Text 3"/>
           <p:cNvSpPr/>
           <p:nvPr/>
         </p:nvSpPr>
@@ -2650,7 +2676,7 @@
       </p:sp>
       <p:sp>
         <p:nvSpPr>
-          <p:cNvPr id="6" name="Text 4"/>
+          <p:cNvPr id="7" name="Text 4"/>
           <p:cNvSpPr/>
           <p:nvPr/>
         </p:nvSpPr>
@@ -2689,7 +2715,7 @@
       </p:sp>
       <p:sp>
         <p:nvSpPr>
-          <p:cNvPr id="7" name="Text 5"/>
+          <p:cNvPr id="8" name="Text 5"/>
           <p:cNvSpPr/>
           <p:nvPr/>
         </p:nvSpPr>
@@ -2728,7 +2754,7 @@
       </p:sp>
       <p:sp>
         <p:nvSpPr>
-          <p:cNvPr id="8" name="Text 6"/>
+          <p:cNvPr id="9" name="Text 6"/>
           <p:cNvSpPr/>
           <p:nvPr/>
         </p:nvSpPr>
@@ -2767,7 +2793,7 @@
       </p:sp>
       <p:sp>
         <p:nvSpPr>
-          <p:cNvPr id="9" name="Text 7"/>
+          <p:cNvPr id="10" name="Text 7"/>
           <p:cNvSpPr/>
           <p:nvPr/>
         </p:nvSpPr>
@@ -2806,7 +2832,7 @@
       </p:sp>
       <p:sp>
         <p:nvSpPr>
-          <p:cNvPr id="10" name="Text 8"/>
+          <p:cNvPr id="11" name="Text 8"/>
           <p:cNvSpPr/>
           <p:nvPr/>
         </p:nvSpPr>
@@ -2845,7 +2871,7 @@
       </p:sp>
       <p:sp>
         <p:nvSpPr>
-          <p:cNvPr id="11" name="Text 9"/>
+          <p:cNvPr id="12" name="Text 9"/>
           <p:cNvSpPr/>
           <p:nvPr/>
         </p:nvSpPr>
@@ -2884,7 +2910,7 @@
       </p:sp>
       <p:sp>
         <p:nvSpPr>
-          <p:cNvPr id="12" name="Text 10"/>
+          <p:cNvPr id="13" name="Text 10"/>
           <p:cNvSpPr/>
           <p:nvPr/>
         </p:nvSpPr>
@@ -2923,7 +2949,7 @@
       </p:sp>
       <p:sp>
         <p:nvSpPr>
-          <p:cNvPr id="13" name="Text 11"/>
+          <p:cNvPr id="14" name="Text 11"/>
           <p:cNvSpPr/>
           <p:nvPr/>
         </p:nvSpPr>
@@ -2962,7 +2988,7 @@
       </p:sp>
       <p:sp>
         <p:nvSpPr>
-          <p:cNvPr id="14" name="Text 12"/>
+          <p:cNvPr id="15" name="Text 12"/>
           <p:cNvSpPr/>
           <p:nvPr/>
         </p:nvSpPr>
@@ -5692,6 +5718,32 @@
           </a:p>
         </p:txBody>
       </p:sp>
+      <p:pic>
+        <p:nvPicPr>
+          <p:cNvPr id="5" name="Image 0" descr="/Users/stuartkerr/Code/Ask-Ruvnet/Ask-Ruvnet/docs/presentations/images/video-thumb-The_Agentic_Stack-mid.jpg">    </p:cNvPr>
+          <p:cNvPicPr>
+            <a:picLocks noChangeAspect="1"/>
+          </p:cNvPicPr>
+          <p:nvPr/>
+        </p:nvPicPr>
+        <p:blipFill>
+          <a:blip r:embed="rId1">
+            <a:alphaModFix amt="25000"/>
+          </a:blip>
+          <a:stretch>
+            <a:fillRect/>
+          </a:stretch>
+        </p:blipFill>
+        <p:spPr>
+          <a:xfrm>
+            <a:off x="5486400" y="182880"/>
+            <a:ext cx="3200400" cy="1828800"/>
+          </a:xfrm>
+          <a:prstGeom prst="rect">
+            <a:avLst/>
+          </a:prstGeom>
+        </p:spPr>
+      </p:pic>
       <p:graphicFrame>
         <p:nvGraphicFramePr>
           <p:cNvPr id="14" name="Table 0"/>
@@ -8192,7 +8244,7 @@
       </p:graphicFrame>
       <p:sp>
         <p:nvSpPr>
-          <p:cNvPr id="6" name="Text 3"/>
+          <p:cNvPr id="7" name="Text 3"/>
           <p:cNvSpPr/>
           <p:nvPr/>
         </p:nvSpPr>
@@ -9559,9 +9611,35 @@
           </a:p>
         </p:txBody>
       </p:sp>
-      <p:sp>
-        <p:nvSpPr>
-          <p:cNvPr id="5" name="Shape 3"/>
+      <p:pic>
+        <p:nvPicPr>
+          <p:cNvPr id="5" name="Image 0" descr="/Users/stuartkerr/Code/Ask-Ruvnet/Ask-Ruvnet/docs/presentations/images/03-compounding-advantage.png">    </p:cNvPr>
+          <p:cNvPicPr>
+            <a:picLocks noChangeAspect="1"/>
+          </p:cNvPicPr>
+          <p:nvPr/>
+        </p:nvPicPr>
+        <p:blipFill>
+          <a:blip r:embed="rId1">
+            <a:alphaModFix amt="7000"/>
+          </a:blip>
+          <a:stretch>
+            <a:fillRect/>
+          </a:stretch>
+        </p:blipFill>
+        <p:spPr>
+          <a:xfrm>
+            <a:off x="0" y="0"/>
+            <a:ext cx="9144000" cy="5143500"/>
+          </a:xfrm>
+          <a:prstGeom prst="rect">
+            <a:avLst/>
+          </a:prstGeom>
+        </p:spPr>
+      </p:pic>
+      <p:sp>
+        <p:nvSpPr>
+          <p:cNvPr id="6" name="Shape 3"/>
           <p:cNvSpPr/>
           <p:nvPr/>
         </p:nvSpPr>
@@ -9588,7 +9666,7 @@
       </p:sp>
       <p:sp>
         <p:nvSpPr>
-          <p:cNvPr id="6" name="Shape 4"/>
+          <p:cNvPr id="7" name="Shape 4"/>
           <p:cNvSpPr/>
           <p:nvPr/>
         </p:nvSpPr>
@@ -9608,7 +9686,7 @@
       </p:sp>
       <p:sp>
         <p:nvSpPr>
-          <p:cNvPr id="7" name="Text 5"/>
+          <p:cNvPr id="8" name="Text 5"/>
           <p:cNvSpPr/>
           <p:nvPr/>
         </p:nvSpPr>
@@ -9647,7 +9725,7 @@
       </p:sp>
       <p:sp>
         <p:nvSpPr>
-          <p:cNvPr id="8" name="Text 6"/>
+          <p:cNvPr id="9" name="Text 6"/>
           <p:cNvSpPr/>
           <p:nvPr/>
         </p:nvSpPr>
@@ -9686,7 +9764,7 @@
       </p:sp>
       <p:sp>
         <p:nvSpPr>
-          <p:cNvPr id="9" name="Shape 7"/>
+          <p:cNvPr id="10" name="Shape 7"/>
           <p:cNvSpPr/>
           <p:nvPr/>
         </p:nvSpPr>
@@ -9713,7 +9791,7 @@
       </p:sp>
       <p:sp>
         <p:nvSpPr>
-          <p:cNvPr id="10" name="Shape 8"/>
+          <p:cNvPr id="11" name="Shape 8"/>
           <p:cNvSpPr/>
           <p:nvPr/>
         </p:nvSpPr>
@@ -9733,7 +9811,7 @@
       </p:sp>
       <p:sp>
         <p:nvSpPr>
-          <p:cNvPr id="11" name="Text 9"/>
+          <p:cNvPr id="12" name="Text 9"/>
           <p:cNvSpPr/>
           <p:nvPr/>
         </p:nvSpPr>
@@ -9772,7 +9850,7 @@
       </p:sp>
       <p:sp>
         <p:nvSpPr>
-          <p:cNvPr id="12" name="Text 10"/>
+          <p:cNvPr id="13" name="Text 10"/>
           <p:cNvSpPr/>
           <p:nvPr/>
         </p:nvSpPr>
@@ -9811,7 +9889,7 @@
       </p:sp>
       <p:sp>
         <p:nvSpPr>
-          <p:cNvPr id="13" name="Shape 11"/>
+          <p:cNvPr id="14" name="Shape 11"/>
           <p:cNvSpPr/>
           <p:nvPr/>
         </p:nvSpPr>
@@ -9838,7 +9916,7 @@
       </p:sp>
       <p:sp>
         <p:nvSpPr>
-          <p:cNvPr id="14" name="Shape 12"/>
+          <p:cNvPr id="15" name="Shape 12"/>
           <p:cNvSpPr/>
           <p:nvPr/>
         </p:nvSpPr>
@@ -9858,7 +9936,7 @@
       </p:sp>
       <p:sp>
         <p:nvSpPr>
-          <p:cNvPr id="15" name="Text 13"/>
+          <p:cNvPr id="16" name="Text 13"/>
           <p:cNvSpPr/>
           <p:nvPr/>
         </p:nvSpPr>
@@ -9897,7 +9975,7 @@
       </p:sp>
       <p:sp>
         <p:nvSpPr>
-          <p:cNvPr id="16" name="Text 14"/>
+          <p:cNvPr id="17" name="Text 14"/>
           <p:cNvSpPr/>
           <p:nvPr/>
         </p:nvSpPr>
@@ -9936,7 +10014,7 @@
       </p:sp>
       <p:sp>
         <p:nvSpPr>
-          <p:cNvPr id="17" name="Shape 15"/>
+          <p:cNvPr id="18" name="Shape 15"/>
           <p:cNvSpPr/>
           <p:nvPr/>
         </p:nvSpPr>
@@ -9963,7 +10041,7 @@
       </p:sp>
       <p:sp>
         <p:nvSpPr>
-          <p:cNvPr id="18" name="Shape 16"/>
+          <p:cNvPr id="19" name="Shape 16"/>
           <p:cNvSpPr/>
           <p:nvPr/>
         </p:nvSpPr>
@@ -9983,7 +10061,7 @@
       </p:sp>
       <p:sp>
         <p:nvSpPr>
-          <p:cNvPr id="19" name="Text 17"/>
+          <p:cNvPr id="20" name="Text 17"/>
           <p:cNvSpPr/>
           <p:nvPr/>
         </p:nvSpPr>
@@ -10022,7 +10100,7 @@
       </p:sp>
       <p:sp>
         <p:nvSpPr>
-          <p:cNvPr id="20" name="Text 18"/>
+          <p:cNvPr id="21" name="Text 18"/>
           <p:cNvSpPr/>
           <p:nvPr/>
         </p:nvSpPr>
@@ -10061,7 +10139,7 @@
       </p:sp>
       <p:sp>
         <p:nvSpPr>
-          <p:cNvPr id="21" name="Shape 19"/>
+          <p:cNvPr id="22" name="Shape 19"/>
           <p:cNvSpPr/>
           <p:nvPr/>
         </p:nvSpPr>
@@ -10081,7 +10159,7 @@
       </p:sp>
       <p:sp>
         <p:nvSpPr>
-          <p:cNvPr id="22" name="Text 20"/>
+          <p:cNvPr id="23" name="Text 20"/>
           <p:cNvSpPr/>
           <p:nvPr/>
         </p:nvSpPr>
@@ -17748,9 +17826,35 @@
           </a:p>
         </p:txBody>
       </p:sp>
-      <p:sp>
-        <p:nvSpPr>
-          <p:cNvPr id="5" name="Shape 3"/>
+      <p:pic>
+        <p:nvPicPr>
+          <p:cNvPr id="5" name="Image 0" descr="/Users/stuartkerr/Code/Ask-Ruvnet/Ask-Ruvnet/docs/presentations/images/01-architecture-overview.png">    </p:cNvPr>
+          <p:cNvPicPr>
+            <a:picLocks noChangeAspect="1"/>
+          </p:cNvPicPr>
+          <p:nvPr/>
+        </p:nvPicPr>
+        <p:blipFill>
+          <a:blip r:embed="rId1">
+            <a:alphaModFix amt="30000"/>
+          </a:blip>
+          <a:stretch>
+            <a:fillRect/>
+          </a:stretch>
+        </p:blipFill>
+        <p:spPr>
+          <a:xfrm>
+            <a:off x="1371600" y="1097280"/>
+            <a:ext cx="6400800" cy="3657600"/>
+          </a:xfrm>
+          <a:prstGeom prst="rect">
+            <a:avLst/>
+          </a:prstGeom>
+        </p:spPr>
+      </p:pic>
+      <p:sp>
+        <p:nvSpPr>
+          <p:cNvPr id="6" name="Shape 3"/>
           <p:cNvSpPr/>
           <p:nvPr/>
         </p:nvSpPr>
@@ -17777,7 +17881,7 @@
       </p:sp>
       <p:sp>
         <p:nvSpPr>
-          <p:cNvPr id="6" name="Shape 4"/>
+          <p:cNvPr id="7" name="Shape 4"/>
           <p:cNvSpPr/>
           <p:nvPr/>
         </p:nvSpPr>
@@ -17797,7 +17901,7 @@
       </p:sp>
       <p:sp>
         <p:nvSpPr>
-          <p:cNvPr id="7" name="Text 5"/>
+          <p:cNvPr id="8" name="Text 5"/>
           <p:cNvSpPr/>
           <p:nvPr/>
         </p:nvSpPr>
@@ -17836,7 +17940,7 @@
       </p:sp>
       <p:sp>
         <p:nvSpPr>
-          <p:cNvPr id="8" name="Text 6"/>
+          <p:cNvPr id="9" name="Text 6"/>
           <p:cNvSpPr/>
           <p:nvPr/>
         </p:nvSpPr>
@@ -17875,7 +17979,7 @@
       </p:sp>
       <p:sp>
         <p:nvSpPr>
-          <p:cNvPr id="9" name="Text 7"/>
+          <p:cNvPr id="10" name="Text 7"/>
           <p:cNvSpPr/>
           <p:nvPr/>
         </p:nvSpPr>
@@ -17931,7 +18035,7 @@
       </p:sp>
       <p:sp>
         <p:nvSpPr>
-          <p:cNvPr id="10" name="Text 8"/>
+          <p:cNvPr id="11" name="Text 8"/>
           <p:cNvSpPr/>
           <p:nvPr/>
         </p:nvSpPr>
@@ -17970,7 +18074,7 @@
       </p:sp>
       <p:sp>
         <p:nvSpPr>
-          <p:cNvPr id="11" name="Shape 9"/>
+          <p:cNvPr id="12" name="Shape 9"/>
           <p:cNvSpPr/>
           <p:nvPr/>
         </p:nvSpPr>
@@ -17997,7 +18101,7 @@
       </p:sp>
       <p:sp>
         <p:nvSpPr>
-          <p:cNvPr id="12" name="Shape 10"/>
+          <p:cNvPr id="13" name="Shape 10"/>
           <p:cNvSpPr/>
           <p:nvPr/>
         </p:nvSpPr>
@@ -18017,7 +18121,7 @@
       </p:sp>
       <p:sp>
         <p:nvSpPr>
-          <p:cNvPr id="13" name="Text 11"/>
+          <p:cNvPr id="14" name="Text 11"/>
           <p:cNvSpPr/>
           <p:nvPr/>
         </p:nvSpPr>
@@ -18056,7 +18160,7 @@
       </p:sp>
       <p:sp>
         <p:nvSpPr>
-          <p:cNvPr id="14" name="Text 12"/>
+          <p:cNvPr id="15" name="Text 12"/>
           <p:cNvSpPr/>
           <p:nvPr/>
         </p:nvSpPr>
@@ -18095,7 +18199,7 @@
       </p:sp>
       <p:sp>
         <p:nvSpPr>
-          <p:cNvPr id="15" name="Text 13"/>
+          <p:cNvPr id="16" name="Text 13"/>
           <p:cNvSpPr/>
           <p:nvPr/>
         </p:nvSpPr>
@@ -18151,7 +18255,7 @@
       </p:sp>
       <p:sp>
         <p:nvSpPr>
-          <p:cNvPr id="16" name="Text 14"/>
+          <p:cNvPr id="17" name="Text 14"/>
           <p:cNvSpPr/>
           <p:nvPr/>
         </p:nvSpPr>
@@ -18190,7 +18294,7 @@
       </p:sp>
       <p:sp>
         <p:nvSpPr>
-          <p:cNvPr id="17" name="Shape 15"/>
+          <p:cNvPr id="18" name="Shape 15"/>
           <p:cNvSpPr/>
           <p:nvPr/>
         </p:nvSpPr>
@@ -18217,7 +18321,7 @@
       </p:sp>
       <p:sp>
         <p:nvSpPr>
-          <p:cNvPr id="18" name="Shape 16"/>
+          <p:cNvPr id="19" name="Shape 16"/>
           <p:cNvSpPr/>
           <p:nvPr/>
         </p:nvSpPr>
@@ -18237,7 +18341,7 @@
       </p:sp>
       <p:sp>
         <p:nvSpPr>
-          <p:cNvPr id="19" name="Text 17"/>
+          <p:cNvPr id="20" name="Text 17"/>
           <p:cNvSpPr/>
           <p:nvPr/>
         </p:nvSpPr>
@@ -18276,7 +18380,7 @@
       </p:sp>
       <p:sp>
         <p:nvSpPr>
-          <p:cNvPr id="20" name="Text 18"/>
+          <p:cNvPr id="21" name="Text 18"/>
           <p:cNvSpPr/>
           <p:nvPr/>
         </p:nvSpPr>
@@ -18315,7 +18419,7 @@
       </p:sp>
       <p:sp>
         <p:nvSpPr>
-          <p:cNvPr id="21" name="Text 19"/>
+          <p:cNvPr id="22" name="Text 19"/>
           <p:cNvSpPr/>
           <p:nvPr/>
         </p:nvSpPr>
@@ -18371,7 +18475,7 @@
       </p:sp>
       <p:sp>
         <p:nvSpPr>
-          <p:cNvPr id="22" name="Text 20"/>
+          <p:cNvPr id="23" name="Text 20"/>
           <p:cNvSpPr/>
           <p:nvPr/>
         </p:nvSpPr>
@@ -18410,7 +18514,7 @@
       </p:sp>
       <p:sp>
         <p:nvSpPr>
-          <p:cNvPr id="23" name="Shape 21"/>
+          <p:cNvPr id="24" name="Shape 21"/>
           <p:cNvSpPr/>
           <p:nvPr/>
         </p:nvSpPr>
@@ -18437,7 +18541,7 @@
       </p:sp>
       <p:sp>
         <p:nvSpPr>
-          <p:cNvPr id="24" name="Shape 22"/>
+          <p:cNvPr id="25" name="Shape 22"/>
           <p:cNvSpPr/>
           <p:nvPr/>
         </p:nvSpPr>
@@ -18457,7 +18561,7 @@
       </p:sp>
       <p:sp>
         <p:nvSpPr>
-          <p:cNvPr id="25" name="Text 23"/>
+          <p:cNvPr id="26" name="Text 23"/>
           <p:cNvSpPr/>
           <p:nvPr/>
         </p:nvSpPr>
@@ -18496,7 +18600,7 @@
       </p:sp>
       <p:sp>
         <p:nvSpPr>
-          <p:cNvPr id="26" name="Text 24"/>
+          <p:cNvPr id="27" name="Text 24"/>
           <p:cNvSpPr/>
           <p:nvPr/>
         </p:nvSpPr>
@@ -18535,7 +18639,7 @@
       </p:sp>
       <p:sp>
         <p:nvSpPr>
-          <p:cNvPr id="27" name="Text 25"/>
+          <p:cNvPr id="28" name="Text 25"/>
           <p:cNvSpPr/>
           <p:nvPr/>
         </p:nvSpPr>
@@ -18591,7 +18695,7 @@
       </p:sp>
       <p:sp>
         <p:nvSpPr>
-          <p:cNvPr id="28" name="Text 26"/>
+          <p:cNvPr id="29" name="Text 26"/>
           <p:cNvSpPr/>
           <p:nvPr/>
         </p:nvSpPr>
@@ -18630,7 +18734,7 @@
       </p:sp>
       <p:sp>
         <p:nvSpPr>
-          <p:cNvPr id="29" name="Shape 27"/>
+          <p:cNvPr id="30" name="Shape 27"/>
           <p:cNvSpPr/>
           <p:nvPr/>
         </p:nvSpPr>
@@ -18657,7 +18761,7 @@
       </p:sp>
       <p:sp>
         <p:nvSpPr>
-          <p:cNvPr id="30" name="Shape 28"/>
+          <p:cNvPr id="31" name="Shape 28"/>
           <p:cNvSpPr/>
           <p:nvPr/>
         </p:nvSpPr>
@@ -18677,7 +18781,7 @@
       </p:sp>
       <p:sp>
         <p:nvSpPr>
-          <p:cNvPr id="31" name="Text 29"/>
+          <p:cNvPr id="32" name="Text 29"/>
           <p:cNvSpPr/>
           <p:nvPr/>
         </p:nvSpPr>
@@ -18716,7 +18820,7 @@
       </p:sp>
       <p:sp>
         <p:nvSpPr>
-          <p:cNvPr id="32" name="Text 30"/>
+          <p:cNvPr id="33" name="Text 30"/>
           <p:cNvSpPr/>
           <p:nvPr/>
         </p:nvSpPr>
@@ -18755,7 +18859,7 @@
       </p:sp>
       <p:sp>
         <p:nvSpPr>
-          <p:cNvPr id="33" name="Text 31"/>
+          <p:cNvPr id="34" name="Text 31"/>
           <p:cNvSpPr/>
           <p:nvPr/>
         </p:nvSpPr>
@@ -18811,7 +18915,7 @@
       </p:sp>
       <p:sp>
         <p:nvSpPr>
-          <p:cNvPr id="34" name="Text 32"/>
+          <p:cNvPr id="35" name="Text 32"/>
           <p:cNvSpPr/>
           <p:nvPr/>
         </p:nvSpPr>
@@ -18850,7 +18954,7 @@
       </p:sp>
       <p:sp>
         <p:nvSpPr>
-          <p:cNvPr id="35" name="Shape 33"/>
+          <p:cNvPr id="36" name="Shape 33"/>
           <p:cNvSpPr/>
           <p:nvPr/>
         </p:nvSpPr>
@@ -18877,7 +18981,7 @@
       </p:sp>
       <p:sp>
         <p:nvSpPr>
-          <p:cNvPr id="36" name="Shape 34"/>
+          <p:cNvPr id="37" name="Shape 34"/>
           <p:cNvSpPr/>
           <p:nvPr/>
         </p:nvSpPr>
@@ -18897,7 +19001,7 @@
       </p:sp>
       <p:sp>
         <p:nvSpPr>
-          <p:cNvPr id="37" name="Text 35"/>
+          <p:cNvPr id="38" name="Text 35"/>
           <p:cNvSpPr/>
           <p:nvPr/>
         </p:nvSpPr>
@@ -18936,7 +19040,7 @@
       </p:sp>
       <p:sp>
         <p:nvSpPr>
-          <p:cNvPr id="38" name="Text 36"/>
+          <p:cNvPr id="39" name="Text 36"/>
           <p:cNvSpPr/>
           <p:nvPr/>
         </p:nvSpPr>
@@ -18975,7 +19079,7 @@
       </p:sp>
       <p:sp>
         <p:nvSpPr>
-          <p:cNvPr id="39" name="Text 37"/>
+          <p:cNvPr id="40" name="Text 37"/>
           <p:cNvSpPr/>
           <p:nvPr/>
         </p:nvSpPr>
@@ -19031,7 +19135,7 @@
       </p:sp>
       <p:sp>
         <p:nvSpPr>
-          <p:cNvPr id="40" name="Text 38"/>
+          <p:cNvPr id="41" name="Text 38"/>
           <p:cNvSpPr/>
           <p:nvPr/>
         </p:nvSpPr>
@@ -21316,9 +21420,35 @@
           </a:p>
         </p:txBody>
       </p:sp>
-      <p:sp>
-        <p:nvSpPr>
-          <p:cNvPr id="5" name="Shape 3"/>
+      <p:pic>
+        <p:nvPicPr>
+          <p:cNvPr id="5" name="Image 0" descr="/Users/stuartkerr/Code/Ask-Ruvnet/Ask-Ruvnet/docs/presentations/images/02-data-sovereignty.png">    </p:cNvPr>
+          <p:cNvPicPr>
+            <a:picLocks noChangeAspect="1"/>
+          </p:cNvPicPr>
+          <p:nvPr/>
+        </p:nvPicPr>
+        <p:blipFill>
+          <a:blip r:embed="rId1">
+            <a:alphaModFix amt="8000"/>
+          </a:blip>
+          <a:stretch>
+            <a:fillRect/>
+          </a:stretch>
+        </p:blipFill>
+        <p:spPr>
+          <a:xfrm>
+            <a:off x="0" y="0"/>
+            <a:ext cx="9144000" cy="5143500"/>
+          </a:xfrm>
+          <a:prstGeom prst="rect">
+            <a:avLst/>
+          </a:prstGeom>
+        </p:spPr>
+      </p:pic>
+      <p:sp>
+        <p:nvSpPr>
+          <p:cNvPr id="6" name="Shape 3"/>
           <p:cNvSpPr/>
           <p:nvPr/>
         </p:nvSpPr>
@@ -21345,7 +21475,7 @@
       </p:sp>
       <p:sp>
         <p:nvSpPr>
-          <p:cNvPr id="6" name="Shape 4"/>
+          <p:cNvPr id="7" name="Shape 4"/>
           <p:cNvSpPr/>
           <p:nvPr/>
         </p:nvSpPr>
@@ -21365,7 +21495,7 @@
       </p:sp>
       <p:sp>
         <p:nvSpPr>
-          <p:cNvPr id="7" name="Text 5"/>
+          <p:cNvPr id="8" name="Text 5"/>
           <p:cNvSpPr/>
           <p:nvPr/>
         </p:nvSpPr>
@@ -21404,7 +21534,7 @@
       </p:sp>
       <p:sp>
         <p:nvSpPr>
-          <p:cNvPr id="8" name="Text 6"/>
+          <p:cNvPr id="9" name="Text 6"/>
           <p:cNvSpPr/>
           <p:nvPr/>
         </p:nvSpPr>
@@ -21531,7 +21661,7 @@
       </p:sp>
       <p:sp>
         <p:nvSpPr>
-          <p:cNvPr id="9" name="Shape 7"/>
+          <p:cNvPr id="10" name="Shape 7"/>
           <p:cNvSpPr/>
           <p:nvPr/>
         </p:nvSpPr>
@@ -21558,7 +21688,7 @@
       </p:sp>
       <p:sp>
         <p:nvSpPr>
-          <p:cNvPr id="10" name="Shape 8"/>
+          <p:cNvPr id="11" name="Shape 8"/>
           <p:cNvSpPr/>
           <p:nvPr/>
         </p:nvSpPr>
@@ -21578,7 +21708,7 @@
       </p:sp>
       <p:sp>
         <p:nvSpPr>
-          <p:cNvPr id="11" name="Text 9"/>
+          <p:cNvPr id="12" name="Text 9"/>
           <p:cNvSpPr/>
           <p:nvPr/>
         </p:nvSpPr>
@@ -21617,7 +21747,7 @@
       </p:sp>
       <p:sp>
         <p:nvSpPr>
-          <p:cNvPr id="12" name="Text 10"/>
+          <p:cNvPr id="13" name="Text 10"/>
           <p:cNvSpPr/>
           <p:nvPr/>
         </p:nvSpPr>
@@ -21744,7 +21874,7 @@
       </p:sp>
       <p:sp>
         <p:nvSpPr>
-          <p:cNvPr id="13" name="Shape 11"/>
+          <p:cNvPr id="14" name="Shape 11"/>
           <p:cNvSpPr/>
           <p:nvPr/>
         </p:nvSpPr>
@@ -21764,7 +21894,7 @@
       </p:sp>
       <p:sp>
         <p:nvSpPr>
-          <p:cNvPr id="14" name="Text 12"/>
+          <p:cNvPr id="15" name="Text 12"/>
           <p:cNvSpPr/>
           <p:nvPr/>
         </p:nvSpPr>
@@ -21803,7 +21933,7 @@
       </p:sp>
       <p:sp>
         <p:nvSpPr>
-          <p:cNvPr id="15" name="Text 13"/>
+          <p:cNvPr id="16" name="Text 13"/>
           <p:cNvSpPr/>
           <p:nvPr/>
         </p:nvSpPr>

</xml_diff>